<commit_message>
Give the submission files their own document properties
The deck's closing slide carried a repository URL, and the four output files
carried whatever their toolchain left behind: python-docx as the author of the
report, python-pptx's own maintainer as last-modified-by on the deck, and
"_report.html" / "_deck.html" as the PDF titles a reader sees in their viewer's
title bar.

All four now declare the team as author and the paper's real title, set from
bodhi/config.TEAM at build time so they cannot drift from the title block. PDF
stamping is skipped silently when PyMuPDF is unavailable.

Co-Authored-By: Claude Opus 5 <noreply@anthropic.com>
Claude-Session: https://claude.ai/code/session_01A8GYsYd9keWSy4bnr49ouz
</commit_message>
<xml_diff>
--- a/docs/BODHI_Mule_Hunter_Deck.pptx
+++ b/docs/BODHI_Mule_Hunter_Deck.pptx
@@ -14411,7 +14411,7 @@
                 </a:solidFill>
                 <a:latin typeface="Segoe UI"/>
               </a:rPr>
-              <a:t>~17.2k</a:t>
+              <a:t>~17.3k</a:t>
             </a:r>
           </a:p>
         </p:txBody>
@@ -15095,7 +15095,7 @@
                 </a:solidFill>
                 <a:latin typeface="Consolas"/>
               </a:rPr>
-              <a:t>make setup &amp;&amp; make all &amp;&amp; make serve      ·      github.com/deepakvish001/BOI-Hackathon-Prototype-</a:t>
+              <a:t>make setup &amp;&amp; make all &amp;&amp; make serve      ·      every number on these slides is regenerated by that command</a:t>
             </a:r>
           </a:p>
         </p:txBody>

</xml_diff>

<commit_message>
Link the submission documents to the source repository
Every deliverable now carries the repository as a live link: the report's title
block and conclusion, the deck's closing slide, the LaTeX source, README and
SUBMISSION.md. Real link annotations in all four output formats, not printed
text - a PDF hyperlink annotation, a Word w:hyperlink relationship (python-docx
has no API for one, so it is built from the XML), and a pptx run hyperlink.

The URL lives in bodhi/config.REPO_URL so the five builders cannot drift, and it
is the only external URL any document contains.

121 tests pass.

Co-Authored-By: Claude Opus 5 <noreply@anthropic.com>
Claude-Session: https://claude.ai/code/session_01A8GYsYd9keWSy4bnr49ouz
</commit_message>
<xml_diff>
--- a/docs/BODHI_Mule_Hunter_Deck.pptx
+++ b/docs/BODHI_Mule_Hunter_Deck.pptx
@@ -15095,7 +15095,17 @@
                 </a:solidFill>
                 <a:latin typeface="Consolas"/>
               </a:rPr>
-              <a:t>make setup &amp;&amp; make all &amp;&amp; make serve      ·      every number on these slides is regenerated by that command</a:t>
+              <a:t>make setup &amp;&amp; make all &amp;&amp; make serve      ·      </a:t>
+            </a:r>
+            <a:r>
+              <a:rPr sz="1100">
+                <a:solidFill>
+                  <a:srgbClr val="4DA3FF"/>
+                </a:solidFill>
+                <a:latin typeface="Consolas"/>
+                <a:hlinkClick r:id="rId2"/>
+              </a:rPr>
+              <a:t>github.com/archirajpoot/Bodhi_Mule_Hunter</a:t>
             </a:r>
           </a:p>
         </p:txBody>

</xml_diff>

<commit_message>
Put the repository link on every page and every slide
It was only on the title block and the conclusion, so a reviewer reading page
four had nothing to click.

Report PDF: a running footer with the link and "n / total" drawn onto each page
after rendering. Chromium implements no `position: running()`, so a print-CSS
footer is not available; the text is placed inside the existing 18 mm bottom
margin with a link annotation over the URL glyphs.

Report DOCX: a real Word footer on both sections - Word does not inherit a
footer across a section break, so each one gets its own.

Deck PPTX and PDF: the link joins the running footer on all 18 numbered slides
and is added to the title slide, which has no footer.

Verified by reading the annotations back: 7/7 report pages, 19/19 slides in both
deck formats. 121 tests pass.

Co-Authored-By: Claude Opus 5 <noreply@anthropic.com>
Claude-Session: https://claude.ai/code/session_01A8GYsYd9keWSy4bnr49ouz
</commit_message>
<xml_diff>
--- a/docs/BODHI_Mule_Hunter_Deck.pptx
+++ b/docs/BODHI_Mule_Hunter_Deck.pptx
@@ -4411,7 +4411,7 @@
         <p:spPr>
           <a:xfrm>
             <a:off x="822960" y="6272784"/>
-            <a:ext cx="10515600" cy="320040"/>
+            <a:ext cx="10515600" cy="274320"/>
           </a:xfrm>
           <a:prstGeom prst="rect">
             <a:avLst/>
@@ -4440,6 +4440,58 @@
                 <a:latin typeface="Segoe UI"/>
               </a:rPr>
               <a:t>Team BODHI   ·   CyberShield Hackathon 2026 - Problem Statement 2   ·   In association with Bank of India and IIT Hyderabad</a:t>
+            </a:r>
+          </a:p>
+        </p:txBody>
+      </p:sp>
+      <p:sp>
+        <p:nvSpPr>
+          <p:cNvPr id="33" name="TextBox 32"/>
+          <p:cNvSpPr txBox="1"/>
+          <p:nvPr/>
+        </p:nvSpPr>
+        <p:spPr>
+          <a:xfrm>
+            <a:off x="822960" y="6492240"/>
+            <a:ext cx="10515600" cy="274320"/>
+          </a:xfrm>
+          <a:prstGeom prst="rect">
+            <a:avLst/>
+          </a:prstGeom>
+          <a:noFill/>
+        </p:spPr>
+        <p:txBody>
+          <a:bodyPr wrap="square" anchor="t" lIns="0" rIns="0" tIns="0" bIns="0">
+            <a:spAutoFit/>
+          </a:bodyPr>
+          <a:lstStyle/>
+          <a:p>
+            <a:pPr algn="l">
+              <a:lnSpc>
+                <a:spcPct val="115000"/>
+              </a:lnSpc>
+              <a:spcAft>
+                <a:spcPts val="400"/>
+              </a:spcAft>
+            </a:pPr>
+            <a:r>
+              <a:rPr sz="1050" b="0">
+                <a:solidFill>
+                  <a:srgbClr val="61708A"/>
+                </a:solidFill>
+                <a:latin typeface="Consolas"/>
+              </a:rPr>
+              <a:t/>
+            </a:r>
+            <a:r>
+              <a:rPr sz="1050">
+                <a:solidFill>
+                  <a:srgbClr val="4DA3FF"/>
+                </a:solidFill>
+                <a:latin typeface="Consolas"/>
+                <a:hlinkClick r:id="rId2"/>
+              </a:rPr>
+              <a:t>github.com/archirajpoot/Bodhi_Mule_Hunter</a:t>
             </a:r>
           </a:p>
         </p:txBody>
@@ -6247,7 +6299,7 @@
         <p:spPr>
           <a:xfrm>
             <a:off x="640080" y="6400800"/>
-            <a:ext cx="8229600" cy="274320"/>
+            <a:ext cx="5852160" cy="274320"/>
           </a:xfrm>
           <a:prstGeom prst="rect">
             <a:avLst/>
@@ -6288,8 +6340,8 @@
         </p:nvSpPr>
         <p:spPr>
           <a:xfrm>
-            <a:off x="10728655" y="6400800"/>
-            <a:ext cx="822960" cy="274320"/>
+            <a:off x="6705295" y="6400800"/>
+            <a:ext cx="4846320" cy="274320"/>
           </a:xfrm>
           <a:prstGeom prst="rect">
             <a:avLst/>
@@ -6315,9 +6367,28 @@
                 <a:solidFill>
                   <a:srgbClr val="61708A"/>
                 </a:solidFill>
-                <a:latin typeface="Segoe UI"/>
-              </a:rPr>
-              <a:t>10 / 19</a:t>
+                <a:latin typeface="Consolas"/>
+              </a:rPr>
+              <a:t/>
+            </a:r>
+            <a:r>
+              <a:rPr sz="950">
+                <a:solidFill>
+                  <a:srgbClr val="61708A"/>
+                </a:solidFill>
+                <a:latin typeface="Consolas"/>
+                <a:hlinkClick r:id="rId2"/>
+              </a:rPr>
+              <a:t>github.com/archirajpoot/Bodhi_Mule_Hunter</a:t>
+            </a:r>
+            <a:r>
+              <a:rPr sz="950">
+                <a:solidFill>
+                  <a:srgbClr val="61708A"/>
+                </a:solidFill>
+                <a:latin typeface="Consolas"/>
+              </a:rPr>
+              <a:t>   ·   10 / 19</a:t>
             </a:r>
           </a:p>
         </p:txBody>
@@ -6592,7 +6663,7 @@
         <p:spPr>
           <a:xfrm>
             <a:off x="640080" y="6400800"/>
-            <a:ext cx="8229600" cy="274320"/>
+            <a:ext cx="5852160" cy="274320"/>
           </a:xfrm>
           <a:prstGeom prst="rect">
             <a:avLst/>
@@ -6633,8 +6704,8 @@
         </p:nvSpPr>
         <p:spPr>
           <a:xfrm>
-            <a:off x="10728655" y="6400800"/>
-            <a:ext cx="822960" cy="274320"/>
+            <a:off x="6705295" y="6400800"/>
+            <a:ext cx="4846320" cy="274320"/>
           </a:xfrm>
           <a:prstGeom prst="rect">
             <a:avLst/>
@@ -6660,9 +6731,28 @@
                 <a:solidFill>
                   <a:srgbClr val="61708A"/>
                 </a:solidFill>
-                <a:latin typeface="Segoe UI"/>
-              </a:rPr>
-              <a:t>11 / 19</a:t>
+                <a:latin typeface="Consolas"/>
+              </a:rPr>
+              <a:t/>
+            </a:r>
+            <a:r>
+              <a:rPr sz="950">
+                <a:solidFill>
+                  <a:srgbClr val="61708A"/>
+                </a:solidFill>
+                <a:latin typeface="Consolas"/>
+                <a:hlinkClick r:id="rId3"/>
+              </a:rPr>
+              <a:t>github.com/archirajpoot/Bodhi_Mule_Hunter</a:t>
+            </a:r>
+            <a:r>
+              <a:rPr sz="950">
+                <a:solidFill>
+                  <a:srgbClr val="61708A"/>
+                </a:solidFill>
+                <a:latin typeface="Consolas"/>
+              </a:rPr>
+              <a:t>   ·   11 / 19</a:t>
             </a:r>
           </a:p>
         </p:txBody>
@@ -7008,7 +7098,7 @@
         <p:spPr>
           <a:xfrm>
             <a:off x="640080" y="6400800"/>
-            <a:ext cx="8229600" cy="274320"/>
+            <a:ext cx="5852160" cy="274320"/>
           </a:xfrm>
           <a:prstGeom prst="rect">
             <a:avLst/>
@@ -7049,8 +7139,8 @@
         </p:nvSpPr>
         <p:spPr>
           <a:xfrm>
-            <a:off x="10728655" y="6400800"/>
-            <a:ext cx="822960" cy="274320"/>
+            <a:off x="6705295" y="6400800"/>
+            <a:ext cx="4846320" cy="274320"/>
           </a:xfrm>
           <a:prstGeom prst="rect">
             <a:avLst/>
@@ -7076,9 +7166,28 @@
                 <a:solidFill>
                   <a:srgbClr val="61708A"/>
                 </a:solidFill>
-                <a:latin typeface="Segoe UI"/>
-              </a:rPr>
-              <a:t>12 / 19</a:t>
+                <a:latin typeface="Consolas"/>
+              </a:rPr>
+              <a:t/>
+            </a:r>
+            <a:r>
+              <a:rPr sz="950">
+                <a:solidFill>
+                  <a:srgbClr val="61708A"/>
+                </a:solidFill>
+                <a:latin typeface="Consolas"/>
+                <a:hlinkClick r:id="rId4"/>
+              </a:rPr>
+              <a:t>github.com/archirajpoot/Bodhi_Mule_Hunter</a:t>
+            </a:r>
+            <a:r>
+              <a:rPr sz="950">
+                <a:solidFill>
+                  <a:srgbClr val="61708A"/>
+                </a:solidFill>
+                <a:latin typeface="Consolas"/>
+              </a:rPr>
+              <a:t>   ·   12 / 19</a:t>
             </a:r>
           </a:p>
         </p:txBody>
@@ -7486,7 +7595,7 @@
         <p:spPr>
           <a:xfrm>
             <a:off x="640080" y="6400800"/>
-            <a:ext cx="8229600" cy="274320"/>
+            <a:ext cx="5852160" cy="274320"/>
           </a:xfrm>
           <a:prstGeom prst="rect">
             <a:avLst/>
@@ -7527,8 +7636,8 @@
         </p:nvSpPr>
         <p:spPr>
           <a:xfrm>
-            <a:off x="10728655" y="6400800"/>
-            <a:ext cx="822960" cy="274320"/>
+            <a:off x="6705295" y="6400800"/>
+            <a:ext cx="4846320" cy="274320"/>
           </a:xfrm>
           <a:prstGeom prst="rect">
             <a:avLst/>
@@ -7554,9 +7663,28 @@
                 <a:solidFill>
                   <a:srgbClr val="61708A"/>
                 </a:solidFill>
-                <a:latin typeface="Segoe UI"/>
-              </a:rPr>
-              <a:t>13 / 19</a:t>
+                <a:latin typeface="Consolas"/>
+              </a:rPr>
+              <a:t/>
+            </a:r>
+            <a:r>
+              <a:rPr sz="950">
+                <a:solidFill>
+                  <a:srgbClr val="61708A"/>
+                </a:solidFill>
+                <a:latin typeface="Consolas"/>
+                <a:hlinkClick r:id="rId3"/>
+              </a:rPr>
+              <a:t>github.com/archirajpoot/Bodhi_Mule_Hunter</a:t>
+            </a:r>
+            <a:r>
+              <a:rPr sz="950">
+                <a:solidFill>
+                  <a:srgbClr val="61708A"/>
+                </a:solidFill>
+                <a:latin typeface="Consolas"/>
+              </a:rPr>
+              <a:t>   ·   13 / 19</a:t>
             </a:r>
           </a:p>
         </p:txBody>
@@ -8533,7 +8661,7 @@
         <p:spPr>
           <a:xfrm>
             <a:off x="640080" y="6400800"/>
-            <a:ext cx="8229600" cy="274320"/>
+            <a:ext cx="5852160" cy="274320"/>
           </a:xfrm>
           <a:prstGeom prst="rect">
             <a:avLst/>
@@ -8574,8 +8702,8 @@
         </p:nvSpPr>
         <p:spPr>
           <a:xfrm>
-            <a:off x="10728655" y="6400800"/>
-            <a:ext cx="822960" cy="274320"/>
+            <a:off x="6705295" y="6400800"/>
+            <a:ext cx="4846320" cy="274320"/>
           </a:xfrm>
           <a:prstGeom prst="rect">
             <a:avLst/>
@@ -8601,9 +8729,28 @@
                 <a:solidFill>
                   <a:srgbClr val="61708A"/>
                 </a:solidFill>
-                <a:latin typeface="Segoe UI"/>
-              </a:rPr>
-              <a:t>14 / 19</a:t>
+                <a:latin typeface="Consolas"/>
+              </a:rPr>
+              <a:t/>
+            </a:r>
+            <a:r>
+              <a:rPr sz="950">
+                <a:solidFill>
+                  <a:srgbClr val="61708A"/>
+                </a:solidFill>
+                <a:latin typeface="Consolas"/>
+                <a:hlinkClick r:id="rId3"/>
+              </a:rPr>
+              <a:t>github.com/archirajpoot/Bodhi_Mule_Hunter</a:t>
+            </a:r>
+            <a:r>
+              <a:rPr sz="950">
+                <a:solidFill>
+                  <a:srgbClr val="61708A"/>
+                </a:solidFill>
+                <a:latin typeface="Consolas"/>
+              </a:rPr>
+              <a:t>   ·   14 / 19</a:t>
             </a:r>
           </a:p>
         </p:txBody>
@@ -9382,7 +9529,7 @@
         <p:spPr>
           <a:xfrm>
             <a:off x="640080" y="6400800"/>
-            <a:ext cx="8229600" cy="274320"/>
+            <a:ext cx="5852160" cy="274320"/>
           </a:xfrm>
           <a:prstGeom prst="rect">
             <a:avLst/>
@@ -9423,8 +9570,8 @@
         </p:nvSpPr>
         <p:spPr>
           <a:xfrm>
-            <a:off x="10728655" y="6400800"/>
-            <a:ext cx="822960" cy="274320"/>
+            <a:off x="6705295" y="6400800"/>
+            <a:ext cx="4846320" cy="274320"/>
           </a:xfrm>
           <a:prstGeom prst="rect">
             <a:avLst/>
@@ -9450,9 +9597,28 @@
                 <a:solidFill>
                   <a:srgbClr val="61708A"/>
                 </a:solidFill>
-                <a:latin typeface="Segoe UI"/>
-              </a:rPr>
-              <a:t>15 / 19</a:t>
+                <a:latin typeface="Consolas"/>
+              </a:rPr>
+              <a:t/>
+            </a:r>
+            <a:r>
+              <a:rPr sz="950">
+                <a:solidFill>
+                  <a:srgbClr val="61708A"/>
+                </a:solidFill>
+                <a:latin typeface="Consolas"/>
+                <a:hlinkClick r:id="rId3"/>
+              </a:rPr>
+              <a:t>github.com/archirajpoot/Bodhi_Mule_Hunter</a:t>
+            </a:r>
+            <a:r>
+              <a:rPr sz="950">
+                <a:solidFill>
+                  <a:srgbClr val="61708A"/>
+                </a:solidFill>
+                <a:latin typeface="Consolas"/>
+              </a:rPr>
+              <a:t>   ·   15 / 19</a:t>
             </a:r>
           </a:p>
         </p:txBody>
@@ -10906,7 +11072,7 @@
         <p:spPr>
           <a:xfrm>
             <a:off x="640080" y="6400800"/>
-            <a:ext cx="8229600" cy="274320"/>
+            <a:ext cx="5852160" cy="274320"/>
           </a:xfrm>
           <a:prstGeom prst="rect">
             <a:avLst/>
@@ -10947,8 +11113,8 @@
         </p:nvSpPr>
         <p:spPr>
           <a:xfrm>
-            <a:off x="10728655" y="6400800"/>
-            <a:ext cx="822960" cy="274320"/>
+            <a:off x="6705295" y="6400800"/>
+            <a:ext cx="4846320" cy="274320"/>
           </a:xfrm>
           <a:prstGeom prst="rect">
             <a:avLst/>
@@ -10974,9 +11140,28 @@
                 <a:solidFill>
                   <a:srgbClr val="61708A"/>
                 </a:solidFill>
-                <a:latin typeface="Segoe UI"/>
-              </a:rPr>
-              <a:t>16 / 19</a:t>
+                <a:latin typeface="Consolas"/>
+              </a:rPr>
+              <a:t/>
+            </a:r>
+            <a:r>
+              <a:rPr sz="950">
+                <a:solidFill>
+                  <a:srgbClr val="61708A"/>
+                </a:solidFill>
+                <a:latin typeface="Consolas"/>
+                <a:hlinkClick r:id="rId2"/>
+              </a:rPr>
+              <a:t>github.com/archirajpoot/Bodhi_Mule_Hunter</a:t>
+            </a:r>
+            <a:r>
+              <a:rPr sz="950">
+                <a:solidFill>
+                  <a:srgbClr val="61708A"/>
+                </a:solidFill>
+                <a:latin typeface="Consolas"/>
+              </a:rPr>
+              <a:t>   ·   16 / 19</a:t>
             </a:r>
           </a:p>
         </p:txBody>
@@ -13108,7 +13293,7 @@
         <p:spPr>
           <a:xfrm>
             <a:off x="640080" y="6400800"/>
-            <a:ext cx="8229600" cy="274320"/>
+            <a:ext cx="5852160" cy="274320"/>
           </a:xfrm>
           <a:prstGeom prst="rect">
             <a:avLst/>
@@ -13149,8 +13334,8 @@
         </p:nvSpPr>
         <p:spPr>
           <a:xfrm>
-            <a:off x="10728655" y="6400800"/>
-            <a:ext cx="822960" cy="274320"/>
+            <a:off x="6705295" y="6400800"/>
+            <a:ext cx="4846320" cy="274320"/>
           </a:xfrm>
           <a:prstGeom prst="rect">
             <a:avLst/>
@@ -13176,9 +13361,28 @@
                 <a:solidFill>
                   <a:srgbClr val="61708A"/>
                 </a:solidFill>
-                <a:latin typeface="Segoe UI"/>
-              </a:rPr>
-              <a:t>17 / 19</a:t>
+                <a:latin typeface="Consolas"/>
+              </a:rPr>
+              <a:t/>
+            </a:r>
+            <a:r>
+              <a:rPr sz="950">
+                <a:solidFill>
+                  <a:srgbClr val="61708A"/>
+                </a:solidFill>
+                <a:latin typeface="Consolas"/>
+                <a:hlinkClick r:id="rId2"/>
+              </a:rPr>
+              <a:t>github.com/archirajpoot/Bodhi_Mule_Hunter</a:t>
+            </a:r>
+            <a:r>
+              <a:rPr sz="950">
+                <a:solidFill>
+                  <a:srgbClr val="61708A"/>
+                </a:solidFill>
+                <a:latin typeface="Consolas"/>
+              </a:rPr>
+              <a:t>   ·   17 / 19</a:t>
             </a:r>
           </a:p>
         </p:txBody>
@@ -13886,7 +14090,7 @@
         <p:spPr>
           <a:xfrm>
             <a:off x="640080" y="6400800"/>
-            <a:ext cx="8229600" cy="274320"/>
+            <a:ext cx="5852160" cy="274320"/>
           </a:xfrm>
           <a:prstGeom prst="rect">
             <a:avLst/>
@@ -13927,8 +14131,8 @@
         </p:nvSpPr>
         <p:spPr>
           <a:xfrm>
-            <a:off x="10728655" y="6400800"/>
-            <a:ext cx="822960" cy="274320"/>
+            <a:off x="6705295" y="6400800"/>
+            <a:ext cx="4846320" cy="274320"/>
           </a:xfrm>
           <a:prstGeom prst="rect">
             <a:avLst/>
@@ -13954,9 +14158,28 @@
                 <a:solidFill>
                   <a:srgbClr val="61708A"/>
                 </a:solidFill>
-                <a:latin typeface="Segoe UI"/>
-              </a:rPr>
-              <a:t>18 / 19</a:t>
+                <a:latin typeface="Consolas"/>
+              </a:rPr>
+              <a:t/>
+            </a:r>
+            <a:r>
+              <a:rPr sz="950">
+                <a:solidFill>
+                  <a:srgbClr val="61708A"/>
+                </a:solidFill>
+                <a:latin typeface="Consolas"/>
+                <a:hlinkClick r:id="rId2"/>
+              </a:rPr>
+              <a:t>github.com/archirajpoot/Bodhi_Mule_Hunter</a:t>
+            </a:r>
+            <a:r>
+              <a:rPr sz="950">
+                <a:solidFill>
+                  <a:srgbClr val="61708A"/>
+                </a:solidFill>
+                <a:latin typeface="Consolas"/>
+              </a:rPr>
+              <a:t>   ·   18 / 19</a:t>
             </a:r>
           </a:p>
         </p:txBody>
@@ -14411,7 +14634,7 @@
                 </a:solidFill>
                 <a:latin typeface="Segoe UI"/>
               </a:rPr>
-              <a:t>~17.3k</a:t>
+              <a:t>~17.4k</a:t>
             </a:r>
           </a:p>
         </p:txBody>
@@ -16215,7 +16438,7 @@
         <p:spPr>
           <a:xfrm>
             <a:off x="640080" y="6400800"/>
-            <a:ext cx="8229600" cy="274320"/>
+            <a:ext cx="5852160" cy="274320"/>
           </a:xfrm>
           <a:prstGeom prst="rect">
             <a:avLst/>
@@ -16256,8 +16479,8 @@
         </p:nvSpPr>
         <p:spPr>
           <a:xfrm>
-            <a:off x="10728655" y="6400800"/>
-            <a:ext cx="822960" cy="274320"/>
+            <a:off x="6705295" y="6400800"/>
+            <a:ext cx="4846320" cy="274320"/>
           </a:xfrm>
           <a:prstGeom prst="rect">
             <a:avLst/>
@@ -16283,9 +16506,28 @@
                 <a:solidFill>
                   <a:srgbClr val="61708A"/>
                 </a:solidFill>
-                <a:latin typeface="Segoe UI"/>
-              </a:rPr>
-              <a:t>2 / 19</a:t>
+                <a:latin typeface="Consolas"/>
+              </a:rPr>
+              <a:t/>
+            </a:r>
+            <a:r>
+              <a:rPr sz="950">
+                <a:solidFill>
+                  <a:srgbClr val="61708A"/>
+                </a:solidFill>
+                <a:latin typeface="Consolas"/>
+                <a:hlinkClick r:id="rId2"/>
+              </a:rPr>
+              <a:t>github.com/archirajpoot/Bodhi_Mule_Hunter</a:t>
+            </a:r>
+            <a:r>
+              <a:rPr sz="950">
+                <a:solidFill>
+                  <a:srgbClr val="61708A"/>
+                </a:solidFill>
+                <a:latin typeface="Consolas"/>
+              </a:rPr>
+              <a:t>   ·   2 / 19</a:t>
             </a:r>
           </a:p>
         </p:txBody>
@@ -16880,7 +17122,7 @@
         <p:spPr>
           <a:xfrm>
             <a:off x="640080" y="6400800"/>
-            <a:ext cx="8229600" cy="274320"/>
+            <a:ext cx="5852160" cy="274320"/>
           </a:xfrm>
           <a:prstGeom prst="rect">
             <a:avLst/>
@@ -16921,8 +17163,8 @@
         </p:nvSpPr>
         <p:spPr>
           <a:xfrm>
-            <a:off x="10728655" y="6400800"/>
-            <a:ext cx="822960" cy="274320"/>
+            <a:off x="6705295" y="6400800"/>
+            <a:ext cx="4846320" cy="274320"/>
           </a:xfrm>
           <a:prstGeom prst="rect">
             <a:avLst/>
@@ -16948,9 +17190,28 @@
                 <a:solidFill>
                   <a:srgbClr val="61708A"/>
                 </a:solidFill>
-                <a:latin typeface="Segoe UI"/>
-              </a:rPr>
-              <a:t>3 / 19</a:t>
+                <a:latin typeface="Consolas"/>
+              </a:rPr>
+              <a:t/>
+            </a:r>
+            <a:r>
+              <a:rPr sz="950">
+                <a:solidFill>
+                  <a:srgbClr val="61708A"/>
+                </a:solidFill>
+                <a:latin typeface="Consolas"/>
+                <a:hlinkClick r:id="rId2"/>
+              </a:rPr>
+              <a:t>github.com/archirajpoot/Bodhi_Mule_Hunter</a:t>
+            </a:r>
+            <a:r>
+              <a:rPr sz="950">
+                <a:solidFill>
+                  <a:srgbClr val="61708A"/>
+                </a:solidFill>
+                <a:latin typeface="Consolas"/>
+              </a:rPr>
+              <a:t>   ·   3 / 19</a:t>
             </a:r>
           </a:p>
         </p:txBody>
@@ -18642,7 +18903,7 @@
         <p:spPr>
           <a:xfrm>
             <a:off x="640080" y="6400800"/>
-            <a:ext cx="8229600" cy="274320"/>
+            <a:ext cx="5852160" cy="274320"/>
           </a:xfrm>
           <a:prstGeom prst="rect">
             <a:avLst/>
@@ -18683,8 +18944,8 @@
         </p:nvSpPr>
         <p:spPr>
           <a:xfrm>
-            <a:off x="10728655" y="6400800"/>
-            <a:ext cx="822960" cy="274320"/>
+            <a:off x="6705295" y="6400800"/>
+            <a:ext cx="4846320" cy="274320"/>
           </a:xfrm>
           <a:prstGeom prst="rect">
             <a:avLst/>
@@ -18710,9 +18971,28 @@
                 <a:solidFill>
                   <a:srgbClr val="61708A"/>
                 </a:solidFill>
-                <a:latin typeface="Segoe UI"/>
-              </a:rPr>
-              <a:t>4 / 19</a:t>
+                <a:latin typeface="Consolas"/>
+              </a:rPr>
+              <a:t/>
+            </a:r>
+            <a:r>
+              <a:rPr sz="950">
+                <a:solidFill>
+                  <a:srgbClr val="61708A"/>
+                </a:solidFill>
+                <a:latin typeface="Consolas"/>
+                <a:hlinkClick r:id="rId2"/>
+              </a:rPr>
+              <a:t>github.com/archirajpoot/Bodhi_Mule_Hunter</a:t>
+            </a:r>
+            <a:r>
+              <a:rPr sz="950">
+                <a:solidFill>
+                  <a:srgbClr val="61708A"/>
+                </a:solidFill>
+                <a:latin typeface="Consolas"/>
+              </a:rPr>
+              <a:t>   ·   4 / 19</a:t>
             </a:r>
           </a:p>
         </p:txBody>
@@ -20284,7 +20564,7 @@
         <p:spPr>
           <a:xfrm>
             <a:off x="640080" y="6400800"/>
-            <a:ext cx="8229600" cy="274320"/>
+            <a:ext cx="5852160" cy="274320"/>
           </a:xfrm>
           <a:prstGeom prst="rect">
             <a:avLst/>
@@ -20325,8 +20605,8 @@
         </p:nvSpPr>
         <p:spPr>
           <a:xfrm>
-            <a:off x="10728655" y="6400800"/>
-            <a:ext cx="822960" cy="274320"/>
+            <a:off x="6705295" y="6400800"/>
+            <a:ext cx="4846320" cy="274320"/>
           </a:xfrm>
           <a:prstGeom prst="rect">
             <a:avLst/>
@@ -20352,9 +20632,28 @@
                 <a:solidFill>
                   <a:srgbClr val="61708A"/>
                 </a:solidFill>
-                <a:latin typeface="Segoe UI"/>
-              </a:rPr>
-              <a:t>5 / 19</a:t>
+                <a:latin typeface="Consolas"/>
+              </a:rPr>
+              <a:t/>
+            </a:r>
+            <a:r>
+              <a:rPr sz="950">
+                <a:solidFill>
+                  <a:srgbClr val="61708A"/>
+                </a:solidFill>
+                <a:latin typeface="Consolas"/>
+                <a:hlinkClick r:id="rId2"/>
+              </a:rPr>
+              <a:t>github.com/archirajpoot/Bodhi_Mule_Hunter</a:t>
+            </a:r>
+            <a:r>
+              <a:rPr sz="950">
+                <a:solidFill>
+                  <a:srgbClr val="61708A"/>
+                </a:solidFill>
+                <a:latin typeface="Consolas"/>
+              </a:rPr>
+              <a:t>   ·   5 / 19</a:t>
             </a:r>
           </a:p>
         </p:txBody>
@@ -21554,7 +21853,7 @@
         <p:spPr>
           <a:xfrm>
             <a:off x="640080" y="6400800"/>
-            <a:ext cx="8229600" cy="274320"/>
+            <a:ext cx="5852160" cy="274320"/>
           </a:xfrm>
           <a:prstGeom prst="rect">
             <a:avLst/>
@@ -21595,8 +21894,8 @@
         </p:nvSpPr>
         <p:spPr>
           <a:xfrm>
-            <a:off x="10728655" y="6400800"/>
-            <a:ext cx="822960" cy="274320"/>
+            <a:off x="6705295" y="6400800"/>
+            <a:ext cx="4846320" cy="274320"/>
           </a:xfrm>
           <a:prstGeom prst="rect">
             <a:avLst/>
@@ -21622,9 +21921,28 @@
                 <a:solidFill>
                   <a:srgbClr val="61708A"/>
                 </a:solidFill>
-                <a:latin typeface="Segoe UI"/>
-              </a:rPr>
-              <a:t>6 / 19</a:t>
+                <a:latin typeface="Consolas"/>
+              </a:rPr>
+              <a:t/>
+            </a:r>
+            <a:r>
+              <a:rPr sz="950">
+                <a:solidFill>
+                  <a:srgbClr val="61708A"/>
+                </a:solidFill>
+                <a:latin typeface="Consolas"/>
+                <a:hlinkClick r:id="rId2"/>
+              </a:rPr>
+              <a:t>github.com/archirajpoot/Bodhi_Mule_Hunter</a:t>
+            </a:r>
+            <a:r>
+              <a:rPr sz="950">
+                <a:solidFill>
+                  <a:srgbClr val="61708A"/>
+                </a:solidFill>
+                <a:latin typeface="Consolas"/>
+              </a:rPr>
+              <a:t>   ·   6 / 19</a:t>
             </a:r>
           </a:p>
         </p:txBody>
@@ -23689,7 +24007,7 @@
         <p:spPr>
           <a:xfrm>
             <a:off x="640080" y="6400800"/>
-            <a:ext cx="8229600" cy="274320"/>
+            <a:ext cx="5852160" cy="274320"/>
           </a:xfrm>
           <a:prstGeom prst="rect">
             <a:avLst/>
@@ -23730,8 +24048,8 @@
         </p:nvSpPr>
         <p:spPr>
           <a:xfrm>
-            <a:off x="10728655" y="6400800"/>
-            <a:ext cx="822960" cy="274320"/>
+            <a:off x="6705295" y="6400800"/>
+            <a:ext cx="4846320" cy="274320"/>
           </a:xfrm>
           <a:prstGeom prst="rect">
             <a:avLst/>
@@ -23757,9 +24075,28 @@
                 <a:solidFill>
                   <a:srgbClr val="61708A"/>
                 </a:solidFill>
-                <a:latin typeface="Segoe UI"/>
-              </a:rPr>
-              <a:t>7 / 19</a:t>
+                <a:latin typeface="Consolas"/>
+              </a:rPr>
+              <a:t/>
+            </a:r>
+            <a:r>
+              <a:rPr sz="950">
+                <a:solidFill>
+                  <a:srgbClr val="61708A"/>
+                </a:solidFill>
+                <a:latin typeface="Consolas"/>
+                <a:hlinkClick r:id="rId3"/>
+              </a:rPr>
+              <a:t>github.com/archirajpoot/Bodhi_Mule_Hunter</a:t>
+            </a:r>
+            <a:r>
+              <a:rPr sz="950">
+                <a:solidFill>
+                  <a:srgbClr val="61708A"/>
+                </a:solidFill>
+                <a:latin typeface="Consolas"/>
+              </a:rPr>
+              <a:t>   ·   7 / 19</a:t>
             </a:r>
           </a:p>
         </p:txBody>
@@ -24991,7 +25328,7 @@
         <p:spPr>
           <a:xfrm>
             <a:off x="640080" y="6400800"/>
-            <a:ext cx="8229600" cy="274320"/>
+            <a:ext cx="5852160" cy="274320"/>
           </a:xfrm>
           <a:prstGeom prst="rect">
             <a:avLst/>
@@ -25032,8 +25369,8 @@
         </p:nvSpPr>
         <p:spPr>
           <a:xfrm>
-            <a:off x="10728655" y="6400800"/>
-            <a:ext cx="822960" cy="274320"/>
+            <a:off x="6705295" y="6400800"/>
+            <a:ext cx="4846320" cy="274320"/>
           </a:xfrm>
           <a:prstGeom prst="rect">
             <a:avLst/>
@@ -25059,9 +25396,28 @@
                 <a:solidFill>
                   <a:srgbClr val="61708A"/>
                 </a:solidFill>
-                <a:latin typeface="Segoe UI"/>
-              </a:rPr>
-              <a:t>8 / 19</a:t>
+                <a:latin typeface="Consolas"/>
+              </a:rPr>
+              <a:t/>
+            </a:r>
+            <a:r>
+              <a:rPr sz="950">
+                <a:solidFill>
+                  <a:srgbClr val="61708A"/>
+                </a:solidFill>
+                <a:latin typeface="Consolas"/>
+                <a:hlinkClick r:id="rId2"/>
+              </a:rPr>
+              <a:t>github.com/archirajpoot/Bodhi_Mule_Hunter</a:t>
+            </a:r>
+            <a:r>
+              <a:rPr sz="950">
+                <a:solidFill>
+                  <a:srgbClr val="61708A"/>
+                </a:solidFill>
+                <a:latin typeface="Consolas"/>
+              </a:rPr>
+              <a:t>   ·   8 / 19</a:t>
             </a:r>
           </a:p>
         </p:txBody>
@@ -26618,7 +26974,7 @@
         <p:spPr>
           <a:xfrm>
             <a:off x="640080" y="6400800"/>
-            <a:ext cx="8229600" cy="274320"/>
+            <a:ext cx="5852160" cy="274320"/>
           </a:xfrm>
           <a:prstGeom prst="rect">
             <a:avLst/>
@@ -26659,8 +27015,8 @@
         </p:nvSpPr>
         <p:spPr>
           <a:xfrm>
-            <a:off x="10728655" y="6400800"/>
-            <a:ext cx="822960" cy="274320"/>
+            <a:off x="6705295" y="6400800"/>
+            <a:ext cx="4846320" cy="274320"/>
           </a:xfrm>
           <a:prstGeom prst="rect">
             <a:avLst/>
@@ -26686,9 +27042,28 @@
                 <a:solidFill>
                   <a:srgbClr val="61708A"/>
                 </a:solidFill>
-                <a:latin typeface="Segoe UI"/>
-              </a:rPr>
-              <a:t>9 / 19</a:t>
+                <a:latin typeface="Consolas"/>
+              </a:rPr>
+              <a:t/>
+            </a:r>
+            <a:r>
+              <a:rPr sz="950">
+                <a:solidFill>
+                  <a:srgbClr val="61708A"/>
+                </a:solidFill>
+                <a:latin typeface="Consolas"/>
+                <a:hlinkClick r:id="rId2"/>
+              </a:rPr>
+              <a:t>github.com/archirajpoot/Bodhi_Mule_Hunter</a:t>
+            </a:r>
+            <a:r>
+              <a:rPr sz="950">
+                <a:solidFill>
+                  <a:srgbClr val="61708A"/>
+                </a:solidFill>
+                <a:latin typeface="Consolas"/>
+              </a:rPr>
+              <a:t>   ·   9 / 19</a:t>
             </a:r>
           </a:p>
         </p:txBody>

</xml_diff>